<commit_message>
crypto-finance-user hidden tests pass (4.84); UTC posting-date bug confirmed
Co-Authored-By: Claude Opus 5.5 <noreply@anthropic.com>
Claude-Session: https://claude.ai/code/session_015s4Kk7vKgcSQ7csnYmEH5j
</commit_message>
<xml_diff>
--- a/team/evals/lead-designer/runs/2026-10-31/task-6/slide-preview.pptx
+++ b/team/evals/lead-designer/runs/2026-10-31/task-6/slide-preview.pptx
@@ -512,7 +512,7 @@
           </a:p>
           <a:p>
             <a:r>
-              <a:t>- "Most stablecoin payments arrive fine; the work is in the ones that don't" [ASSUMPTION]: our own view, not measured. Marked ◦ on the subtitle.</a:t>
+              <a:t>- "Most arrive fine. The work is in the ones that don't" [ASSUMPTION]: our own view, not measured. Marked ◦ on the subtitle.</a:t>
             </a:r>
           </a:p>
           <a:p>
@@ -3606,7 +3606,7 @@
                 </a:solidFill>
                 <a:latin typeface="Arial"/>
               </a:rPr>
-              <a:t>Most stablecoin payments arrive fine; the work is in the ones that don't</a:t>
+              <a:t>Most arrive fine. The work is in the ones that don't</a:t>
             </a:r>
             <a:r>
               <a:rPr sz="2000" b="1" i="0">
@@ -4161,7 +4161,7 @@
                 </a:solidFill>
                 <a:latin typeface="Arial"/>
               </a:rPr>
-              <a:t>real public transfers checked correctly in our own test, not a customer result</a:t>
+              <a:t>real public transfers checked right. Our own test, not a customer result</a:t>
             </a:r>
           </a:p>
         </p:txBody>
@@ -4288,7 +4288,7 @@
                 </a:solidFill>
                 <a:latin typeface="Arial"/>
               </a:rPr>
-              <a:t>per problem payment: our guess, not yet measured</a:t>
+              <a:t>per problem payment. Our guess, not measured</a:t>
             </a:r>
           </a:p>
         </p:txBody>

</xml_diff>